<commit_message>
Wire workshop cards to handouts and fix resource filters
</commit_message>
<xml_diff>
--- a/docs/content/presentation.pptx
+++ b/docs/content/presentation.pptx
@@ -6614,6 +6614,14 @@
 <file path=ppt/slides/slide1.xml><?xml version="1.0" encoding="utf-8"?>
 <p:sld xmlns:a="http://schemas.openxmlformats.org/drawingml/2006/main" xmlns:r="http://schemas.openxmlformats.org/officeDocument/2006/relationships" xmlns:p="http://schemas.openxmlformats.org/presentationml/2006/main">
   <p:cSld>
+    <p:bg>
+      <p:bgPr>
+        <a:solidFill>
+          <a:schemeClr val="bg1"/>
+        </a:solidFill>
+        <a:effectLst/>
+      </p:bgPr>
+    </p:bg>
     <p:spTree>
       <p:nvGrpSpPr>
         <p:cNvPr id="1" name=""/>
@@ -6628,87 +6636,144 @@
           <a:chExt cx="0" cy="0"/>
         </a:xfrm>
       </p:grpSpPr>
-      <p:sp>
-        <p:nvSpPr>
-          <p:cNvPr id="2" name="Title 1"/>
-          <p:cNvSpPr>
-            <a:spLocks noGrp="1"/>
-          </p:cNvSpPr>
-          <p:nvPr>
-            <p:ph type="ctrTitle"/>
+      <p:sp useBgFill="1">
+        <p:nvSpPr>
+          <p:cNvPr id="19" name="Rectangle 18">
+            <a:extLst>
+              <a:ext uri="{FF2B5EF4-FFF2-40B4-BE49-F238E27FC236}">
+                <a16:creationId xmlns:a16="http://schemas.microsoft.com/office/drawing/2014/main" id="{7DA3C418-758E-4180-A5D0-8655D6804587}"/>
+              </a:ext>
+              <a:ext uri="{C183D7F6-B498-43B3-948B-1728B52AA6E4}">
+                <adec:decorative xmlns:adec="http://schemas.microsoft.com/office/drawing/2017/decorative" val="1"/>
+              </a:ext>
+            </a:extLst>
+          </p:cNvPr>
+          <p:cNvSpPr>
+            <a:spLocks noGrp="1" noRot="1" noChangeAspect="1" noMove="1" noResize="1" noEditPoints="1" noAdjustHandles="1" noChangeArrowheads="1" noChangeShapeType="1" noTextEdit="1"/>
+          </p:cNvSpPr>
+          <p:nvPr>
+            <p:extLst>
+              <p:ext uri="{386F3935-93C4-4BCD-93E2-E3B085C9AB24}">
+                <p16:designElem xmlns:p16="http://schemas.microsoft.com/office/powerpoint/2015/main" val="1"/>
+              </p:ext>
+            </p:extLst>
           </p:nvPr>
         </p:nvSpPr>
         <p:spPr>
           <a:xfrm>
-            <a:off x="685800" y="1597819"/>
-            <a:ext cx="7772400" cy="1102519"/>
+            <a:off x="0" y="0"/>
+            <a:ext cx="9144000" cy="5143500"/>
           </a:xfrm>
+          <a:prstGeom prst="rect">
+            <a:avLst/>
+          </a:prstGeom>
+          <a:ln w="12700" cap="flat" cmpd="sng" algn="ctr">
+            <a:noFill/>
+            <a:prstDash val="solid"/>
+            <a:miter lim="800000"/>
+          </a:ln>
+          <a:effectLst/>
+          <a:extLst>
+            <a:ext uri="{91240B29-F687-4F45-9708-019B960494DF}">
+              <a14:hiddenLine xmlns:a14="http://schemas.microsoft.com/office/drawing/2010/main" w="12700" cap="flat" cmpd="sng" algn="ctr">
+                <a:solidFill>
+                  <a:schemeClr val="accent1">
+                    <a:shade val="50000"/>
+                  </a:schemeClr>
+                </a:solidFill>
+                <a:prstDash val="solid"/>
+                <a:miter lim="800000"/>
+              </a14:hiddenLine>
+            </a:ext>
+          </a:extLst>
         </p:spPr>
-        <p:txBody>
-          <a:bodyPr/>
+        <p:style>
+          <a:lnRef idx="2">
+            <a:schemeClr val="accent1">
+              <a:shade val="50000"/>
+            </a:schemeClr>
+          </a:lnRef>
+          <a:fillRef idx="1">
+            <a:schemeClr val="accent1"/>
+          </a:fillRef>
+          <a:effectRef idx="0">
+            <a:schemeClr val="accent1"/>
+          </a:effectRef>
+          <a:fontRef idx="minor">
+            <a:schemeClr val="lt1"/>
+          </a:fontRef>
+        </p:style>
+        <p:txBody>
+          <a:bodyPr rtlCol="0" anchor="ctr"/>
           <a:lstStyle/>
           <a:p>
-            <a:pPr marL="0" lvl="0" indent="0">
-              <a:buNone/>
-            </a:pPr>
-            <a:r>
-              <a:t>AI in Pedagogical Design and Delivery</a:t>
-            </a:r>
-          </a:p>
-        </p:txBody>
-      </p:sp>
-      <p:sp>
-        <p:nvSpPr>
-          <p:cNvPr id="3" name="Subtitle 2"/>
-          <p:cNvSpPr>
-            <a:spLocks noGrp="1"/>
-          </p:cNvSpPr>
-          <p:nvPr>
-            <p:ph type="subTitle" idx="1"/>
+            <a:pPr algn="ctr"/>
+            <a:endParaRPr lang="en-US"/>
+          </a:p>
+        </p:txBody>
+      </p:sp>
+      <p:sp>
+        <p:nvSpPr>
+          <p:cNvPr id="21" name="Rectangle 20">
+            <a:extLst>
+              <a:ext uri="{FF2B5EF4-FFF2-40B4-BE49-F238E27FC236}">
+                <a16:creationId xmlns:a16="http://schemas.microsoft.com/office/drawing/2014/main" id="{28C8EF06-5EC3-4883-AFAF-D74FF46550FB}"/>
+              </a:ext>
+              <a:ext uri="{C183D7F6-B498-43B3-948B-1728B52AA6E4}">
+                <adec:decorative xmlns:adec="http://schemas.microsoft.com/office/drawing/2017/decorative" val="1"/>
+              </a:ext>
+            </a:extLst>
+          </p:cNvPr>
+          <p:cNvSpPr>
+            <a:spLocks noGrp="1" noRot="1" noChangeAspect="1" noMove="1" noResize="1" noEditPoints="1" noAdjustHandles="1" noChangeArrowheads="1" noChangeShapeType="1" noTextEdit="1"/>
+          </p:cNvSpPr>
+          <p:nvPr>
+            <p:extLst>
+              <p:ext uri="{386F3935-93C4-4BCD-93E2-E3B085C9AB24}">
+                <p16:designElem xmlns:p16="http://schemas.microsoft.com/office/powerpoint/2015/main" val="1"/>
+              </p:ext>
+            </p:extLst>
           </p:nvPr>
         </p:nvSpPr>
         <p:spPr>
           <a:xfrm>
-            <a:off x="1371600" y="2914650"/>
-            <a:ext cx="6400800" cy="1314450"/>
+            <a:off x="-2" y="0"/>
+            <a:ext cx="3851978" cy="5153736"/>
           </a:xfrm>
+          <a:prstGeom prst="rect">
+            <a:avLst/>
+          </a:prstGeom>
+          <a:solidFill>
+            <a:srgbClr val="82766A">
+              <a:alpha val="15000"/>
+            </a:srgbClr>
+          </a:solidFill>
+          <a:ln>
+            <a:noFill/>
+          </a:ln>
         </p:spPr>
-        <p:txBody>
-          <a:bodyPr/>
+        <p:style>
+          <a:lnRef idx="2">
+            <a:schemeClr val="accent1">
+              <a:shade val="50000"/>
+            </a:schemeClr>
+          </a:lnRef>
+          <a:fillRef idx="1">
+            <a:schemeClr val="accent1"/>
+          </a:fillRef>
+          <a:effectRef idx="0">
+            <a:schemeClr val="accent1"/>
+          </a:effectRef>
+          <a:fontRef idx="minor">
+            <a:schemeClr val="lt1"/>
+          </a:fontRef>
+        </p:style>
+        <p:txBody>
+          <a:bodyPr rtlCol="0" anchor="ctr"/>
           <a:lstStyle/>
           <a:p>
-            <a:pPr marL="0" lvl="0" indent="0">
-              <a:buNone/>
-            </a:pPr>
-            <a:br/>
-            <a:br/>
-            <a:r>
-              <a:t>Michael Borck</a:t>
-            </a:r>
-          </a:p>
-        </p:txBody>
-      </p:sp>
-      <p:sp>
-        <p:nvSpPr>
-          <p:cNvPr id="4" name="Date Placeholder 3"/>
-          <p:cNvSpPr>
-            <a:spLocks noGrp="1"/>
-          </p:cNvSpPr>
-          <p:nvPr>
-            <p:ph type="dt" sz="half" idx="10"/>
-          </p:nvPr>
-        </p:nvSpPr>
-        <p:spPr/>
-        <p:txBody>
-          <a:bodyPr/>
-          <a:lstStyle/>
-          <a:p>
-            <a:pPr marL="0" lvl="0" indent="0">
-              <a:buNone/>
-            </a:pPr>
-            <a:r>
-              <a:t>2025-11-17</a:t>
-            </a:r>
+            <a:pPr algn="ctr"/>
+            <a:endParaRPr lang="en-US"/>
           </a:p>
         </p:txBody>
       </p:sp>
@@ -6728,26 +6793,639 @@
         </p:nvPicPr>
         <p:blipFill>
           <a:blip r:embed="rId3"/>
+          <a:srcRect l="4005" r="11454"/>
           <a:stretch>
             <a:fillRect/>
           </a:stretch>
         </p:blipFill>
         <p:spPr bwMode="auto">
           <a:xfrm>
-            <a:off x="1854200" y="1193800"/>
-            <a:ext cx="5422900" cy="3390900"/>
+            <a:off x="2186591" y="10"/>
+            <a:ext cx="6957409" cy="5143490"/>
           </a:xfrm>
-          <a:prstGeom prst="rect">
+          <a:custGeom>
             <a:avLst/>
-          </a:prstGeom>
+            <a:gdLst/>
+            <a:ahLst/>
+            <a:cxnLst/>
+            <a:rect l="l" t="t" r="r" b="b"/>
+            <a:pathLst>
+              <a:path w="9276545" h="6871647">
+                <a:moveTo>
+                  <a:pt x="9276545" y="0"/>
+                </a:moveTo>
+                <a:lnTo>
+                  <a:pt x="9276545" y="6858000"/>
+                </a:lnTo>
+                <a:lnTo>
+                  <a:pt x="1546051" y="6871647"/>
+                </a:lnTo>
+                <a:lnTo>
+                  <a:pt x="1535751" y="6828910"/>
+                </a:lnTo>
+                <a:cubicBezTo>
+                  <a:pt x="1530460" y="6775140"/>
+                  <a:pt x="1515370" y="6618042"/>
+                  <a:pt x="1514301" y="6549029"/>
+                </a:cubicBezTo>
+                <a:cubicBezTo>
+                  <a:pt x="1518045" y="6491396"/>
+                  <a:pt x="1528503" y="6450608"/>
+                  <a:pt x="1529339" y="6414828"/>
+                </a:cubicBezTo>
+                <a:cubicBezTo>
+                  <a:pt x="1525062" y="6359280"/>
+                  <a:pt x="1502062" y="6307149"/>
+                  <a:pt x="1493941" y="6268848"/>
+                </a:cubicBezTo>
+                <a:cubicBezTo>
+                  <a:pt x="1502669" y="6254191"/>
+                  <a:pt x="1469920" y="6200171"/>
+                  <a:pt x="1480613" y="6185025"/>
+                </a:cubicBezTo>
+                <a:cubicBezTo>
+                  <a:pt x="1481020" y="6164522"/>
+                  <a:pt x="1458164" y="6060790"/>
+                  <a:pt x="1443364" y="6018360"/>
+                </a:cubicBezTo>
+                <a:cubicBezTo>
+                  <a:pt x="1426694" y="5970758"/>
+                  <a:pt x="1390307" y="5920074"/>
+                  <a:pt x="1380584" y="5899407"/>
+                </a:cubicBezTo>
+                <a:cubicBezTo>
+                  <a:pt x="1370860" y="5878740"/>
+                  <a:pt x="1392244" y="5920877"/>
+                  <a:pt x="1385023" y="5894356"/>
+                </a:cubicBezTo>
+                <a:cubicBezTo>
+                  <a:pt x="1377800" y="5867835"/>
+                  <a:pt x="1345702" y="5770498"/>
+                  <a:pt x="1337254" y="5740279"/>
+                </a:cubicBezTo>
+                <a:cubicBezTo>
+                  <a:pt x="1353956" y="5738860"/>
+                  <a:pt x="1323673" y="5722040"/>
+                  <a:pt x="1334321" y="5713042"/>
+                </a:cubicBezTo>
+                <a:cubicBezTo>
+                  <a:pt x="1343675" y="5706701"/>
+                  <a:pt x="1336672" y="5700118"/>
+                  <a:pt x="1335877" y="5692870"/>
+                </a:cubicBezTo>
+                <a:cubicBezTo>
+                  <a:pt x="1343201" y="5683812"/>
+                  <a:pt x="1329617" y="5652064"/>
+                  <a:pt x="1319978" y="5643427"/>
+                </a:cubicBezTo>
+                <a:cubicBezTo>
+                  <a:pt x="1286551" y="5622177"/>
+                  <a:pt x="1310947" y="5579803"/>
+                  <a:pt x="1285321" y="5562271"/>
+                </a:cubicBezTo>
+                <a:cubicBezTo>
+                  <a:pt x="1281540" y="5556238"/>
+                  <a:pt x="1279983" y="5550455"/>
+                  <a:pt x="1279815" y="5544867"/>
+                </a:cubicBezTo>
+                <a:lnTo>
+                  <a:pt x="1282507" y="5529404"/>
+                </a:lnTo>
+                <a:lnTo>
+                  <a:pt x="1289604" y="5525378"/>
+                </a:lnTo>
+                <a:lnTo>
+                  <a:pt x="1287766" y="5515726"/>
+                </a:lnTo>
+                <a:lnTo>
+                  <a:pt x="1288829" y="5513051"/>
+                </a:lnTo>
+                <a:cubicBezTo>
+                  <a:pt x="1290896" y="5507946"/>
+                  <a:pt x="1292688" y="5502897"/>
+                  <a:pt x="1293373" y="5497833"/>
+                </a:cubicBezTo>
+                <a:cubicBezTo>
+                  <a:pt x="1288690" y="5483829"/>
+                  <a:pt x="1272696" y="5459278"/>
+                  <a:pt x="1260736" y="5429027"/>
+                </a:cubicBezTo>
+                <a:cubicBezTo>
+                  <a:pt x="1238579" y="5396416"/>
+                  <a:pt x="1238884" y="5351600"/>
+                  <a:pt x="1221610" y="5316328"/>
+                </a:cubicBezTo>
+                <a:lnTo>
+                  <a:pt x="1216099" y="5309330"/>
+                </a:lnTo>
+                <a:lnTo>
+                  <a:pt x="1217278" y="5279477"/>
+                </a:lnTo>
+                <a:cubicBezTo>
+                  <a:pt x="1221588" y="5274318"/>
+                  <a:pt x="1222716" y="5266940"/>
+                  <a:pt x="1218469" y="5260597"/>
+                </a:cubicBezTo>
+                <a:lnTo>
+                  <a:pt x="1206220" y="5152555"/>
+                </a:lnTo>
+                <a:cubicBezTo>
+                  <a:pt x="1205294" y="5116878"/>
+                  <a:pt x="1196908" y="5101727"/>
+                  <a:pt x="1212921" y="5046536"/>
+                </a:cubicBezTo>
+                <a:cubicBezTo>
+                  <a:pt x="1234138" y="4987918"/>
+                  <a:pt x="1204801" y="4903116"/>
+                  <a:pt x="1212183" y="4837345"/>
+                </a:cubicBezTo>
+                <a:cubicBezTo>
+                  <a:pt x="1183151" y="4802424"/>
+                  <a:pt x="1209228" y="4821062"/>
+                  <a:pt x="1202048" y="4784195"/>
+                </a:cubicBezTo>
+                <a:cubicBezTo>
+                  <a:pt x="1202483" y="4760878"/>
+                  <a:pt x="1202919" y="4737561"/>
+                  <a:pt x="1203354" y="4714245"/>
+                </a:cubicBezTo>
+                <a:lnTo>
+                  <a:pt x="1201502" y="4700836"/>
+                </a:lnTo>
+                <a:lnTo>
+                  <a:pt x="1194919" y="4697224"/>
+                </a:lnTo>
+                <a:lnTo>
+                  <a:pt x="1187792" y="4677162"/>
+                </a:lnTo>
+                <a:cubicBezTo>
+                  <a:pt x="1186060" y="4669625"/>
+                  <a:pt x="1185291" y="4661478"/>
+                  <a:pt x="1186080" y="4652429"/>
+                </a:cubicBezTo>
+                <a:cubicBezTo>
+                  <a:pt x="1199189" y="4622456"/>
+                  <a:pt x="1167081" y="4571771"/>
+                  <a:pt x="1184722" y="4534840"/>
+                </a:cubicBezTo>
+                <a:cubicBezTo>
+                  <a:pt x="1182407" y="4499077"/>
+                  <a:pt x="1175424" y="4460227"/>
+                  <a:pt x="1172188" y="4437851"/>
+                </a:cubicBezTo>
+                <a:cubicBezTo>
+                  <a:pt x="1161331" y="4428466"/>
+                  <a:pt x="1178123" y="4398274"/>
+                  <a:pt x="1165306" y="4400581"/>
+                </a:cubicBezTo>
+                <a:cubicBezTo>
+                  <a:pt x="1171061" y="4389819"/>
+                  <a:pt x="1173552" y="4346771"/>
+                  <a:pt x="1168602" y="4335651"/>
+                </a:cubicBezTo>
+                <a:lnTo>
+                  <a:pt x="1178384" y="4280215"/>
+                </a:lnTo>
+                <a:lnTo>
+                  <a:pt x="1177294" y="4274660"/>
+                </a:lnTo>
+                <a:cubicBezTo>
+                  <a:pt x="1177138" y="4268882"/>
+                  <a:pt x="1177520" y="4251103"/>
+                  <a:pt x="1177448" y="4245552"/>
+                </a:cubicBezTo>
+                <a:cubicBezTo>
+                  <a:pt x="1177252" y="4244155"/>
+                  <a:pt x="1177058" y="4242757"/>
+                  <a:pt x="1176863" y="4241361"/>
+                </a:cubicBezTo>
+                <a:lnTo>
+                  <a:pt x="1162386" y="4207167"/>
+                </a:lnTo>
+                <a:cubicBezTo>
+                  <a:pt x="1162950" y="4202536"/>
+                  <a:pt x="1174655" y="4199565"/>
+                  <a:pt x="1174343" y="4192380"/>
+                </a:cubicBezTo>
+                <a:lnTo>
+                  <a:pt x="1160516" y="4164062"/>
+                </a:lnTo>
+                <a:lnTo>
+                  <a:pt x="1161365" y="4158623"/>
+                </a:lnTo>
+                <a:lnTo>
+                  <a:pt x="1144878" y="4076261"/>
+                </a:lnTo>
+                <a:lnTo>
+                  <a:pt x="1123687" y="4005692"/>
+                </a:lnTo>
+                <a:lnTo>
+                  <a:pt x="1096720" y="3754257"/>
+                </a:lnTo>
+                <a:cubicBezTo>
+                  <a:pt x="1083618" y="3639924"/>
+                  <a:pt x="1064313" y="3636659"/>
+                  <a:pt x="1047682" y="3517638"/>
+                </a:cubicBezTo>
+                <a:cubicBezTo>
+                  <a:pt x="1048550" y="3477187"/>
+                  <a:pt x="1049418" y="3436735"/>
+                  <a:pt x="1050285" y="3396284"/>
+                </a:cubicBezTo>
+                <a:lnTo>
+                  <a:pt x="1030166" y="3320814"/>
+                </a:lnTo>
+                <a:lnTo>
+                  <a:pt x="1034128" y="3260443"/>
+                </a:lnTo>
+                <a:lnTo>
+                  <a:pt x="1007751" y="3198916"/>
+                </a:lnTo>
+                <a:cubicBezTo>
+                  <a:pt x="1003323" y="3193074"/>
+                  <a:pt x="1001150" y="3187393"/>
+                  <a:pt x="1000384" y="3181839"/>
+                </a:cubicBezTo>
+                <a:cubicBezTo>
+                  <a:pt x="1000734" y="3176675"/>
+                  <a:pt x="1001085" y="3171511"/>
+                  <a:pt x="1001435" y="3166346"/>
+                </a:cubicBezTo>
+                <a:lnTo>
+                  <a:pt x="968918" y="3112638"/>
+                </a:lnTo>
+                <a:cubicBezTo>
+                  <a:pt x="957125" y="3092489"/>
+                  <a:pt x="955617" y="3065232"/>
+                  <a:pt x="934483" y="3031628"/>
+                </a:cubicBezTo>
+                <a:cubicBezTo>
+                  <a:pt x="914631" y="2997037"/>
+                  <a:pt x="908933" y="3005661"/>
+                  <a:pt x="879229" y="2948196"/>
+                </a:cubicBezTo>
+                <a:cubicBezTo>
+                  <a:pt x="850845" y="2897154"/>
+                  <a:pt x="820829" y="2806798"/>
+                  <a:pt x="798666" y="2761198"/>
+                </a:cubicBezTo>
+                <a:cubicBezTo>
+                  <a:pt x="773970" y="2714562"/>
+                  <a:pt x="758278" y="2715446"/>
+                  <a:pt x="746962" y="2694939"/>
+                </a:cubicBezTo>
+                <a:lnTo>
+                  <a:pt x="712796" y="2614779"/>
+                </a:lnTo>
+                <a:lnTo>
+                  <a:pt x="697701" y="2600020"/>
+                </a:lnTo>
+                <a:cubicBezTo>
+                  <a:pt x="697743" y="2598787"/>
+                  <a:pt x="697784" y="2597555"/>
+                  <a:pt x="697823" y="2596321"/>
+                </a:cubicBezTo>
+                <a:lnTo>
+                  <a:pt x="679645" y="2572602"/>
+                </a:lnTo>
+                <a:lnTo>
+                  <a:pt x="680789" y="2571831"/>
+                </a:lnTo>
+                <a:cubicBezTo>
+                  <a:pt x="682946" y="2569560"/>
+                  <a:pt x="683757" y="2566863"/>
+                  <a:pt x="681771" y="2563200"/>
+                </a:cubicBezTo>
+                <a:cubicBezTo>
+                  <a:pt x="705290" y="2562299"/>
+                  <a:pt x="688388" y="2558438"/>
+                  <a:pt x="680456" y="2547723"/>
+                </a:cubicBezTo>
+                <a:cubicBezTo>
+                  <a:pt x="679482" y="2534148"/>
+                  <a:pt x="677183" y="2493617"/>
+                  <a:pt x="675922" y="2481749"/>
+                </a:cubicBezTo>
+                <a:lnTo>
+                  <a:pt x="672894" y="2476509"/>
+                </a:lnTo>
+                <a:lnTo>
+                  <a:pt x="673143" y="2476297"/>
+                </a:lnTo>
+                <a:cubicBezTo>
+                  <a:pt x="673152" y="2474932"/>
+                  <a:pt x="672405" y="2473126"/>
+                  <a:pt x="670567" y="2470561"/>
+                </a:cubicBezTo>
+                <a:lnTo>
+                  <a:pt x="667369" y="2466951"/>
+                </a:lnTo>
+                <a:lnTo>
+                  <a:pt x="661495" y="2456785"/>
+                </a:lnTo>
+                <a:cubicBezTo>
+                  <a:pt x="661510" y="2455387"/>
+                  <a:pt x="661525" y="2453987"/>
+                  <a:pt x="661540" y="2452588"/>
+                </a:cubicBezTo>
+                <a:lnTo>
+                  <a:pt x="664540" y="2449913"/>
+                </a:lnTo>
+                <a:lnTo>
+                  <a:pt x="663581" y="2449129"/>
+                </a:lnTo>
+                <a:cubicBezTo>
+                  <a:pt x="653014" y="2444453"/>
+                  <a:pt x="642406" y="2445872"/>
+                  <a:pt x="663129" y="2426579"/>
+                </a:cubicBezTo>
+                <a:cubicBezTo>
+                  <a:pt x="643271" y="2414167"/>
+                  <a:pt x="657229" y="2404769"/>
+                  <a:pt x="650205" y="2379928"/>
+                </a:cubicBezTo>
+                <a:cubicBezTo>
+                  <a:pt x="634911" y="2374359"/>
+                  <a:pt x="634260" y="2365346"/>
+                  <a:pt x="638008" y="2354824"/>
+                </a:cubicBezTo>
+                <a:cubicBezTo>
+                  <a:pt x="621083" y="2334576"/>
+                  <a:pt x="620949" y="2310146"/>
+                  <a:pt x="609851" y="2284299"/>
+                </a:cubicBezTo>
+                <a:lnTo>
+                  <a:pt x="585585" y="2155739"/>
+                </a:lnTo>
+                <a:lnTo>
+                  <a:pt x="581391" y="2152892"/>
+                </a:lnTo>
+                <a:cubicBezTo>
+                  <a:pt x="578821" y="2150768"/>
+                  <a:pt x="577525" y="2149149"/>
+                  <a:pt x="577083" y="2147807"/>
+                </a:cubicBezTo>
+                <a:lnTo>
+                  <a:pt x="577251" y="2147544"/>
+                </a:lnTo>
+                <a:lnTo>
+                  <a:pt x="546845" y="2085601"/>
+                </a:lnTo>
+                <a:cubicBezTo>
+                  <a:pt x="538270" y="2073917"/>
+                  <a:pt x="486356" y="1955894"/>
+                  <a:pt x="470837" y="1931362"/>
+                </a:cubicBezTo>
+                <a:lnTo>
+                  <a:pt x="428154" y="1657167"/>
+                </a:lnTo>
+                <a:lnTo>
+                  <a:pt x="392797" y="1510175"/>
+                </a:lnTo>
+                <a:cubicBezTo>
+                  <a:pt x="380165" y="1504446"/>
+                  <a:pt x="369910" y="1451095"/>
+                  <a:pt x="372847" y="1440507"/>
+                </a:cubicBezTo>
+                <a:cubicBezTo>
+                  <a:pt x="369015" y="1433783"/>
+                  <a:pt x="338503" y="1376212"/>
+                  <a:pt x="344479" y="1367690"/>
+                </a:cubicBezTo>
+                <a:cubicBezTo>
+                  <a:pt x="332264" y="1342150"/>
+                  <a:pt x="321736" y="1310521"/>
+                  <a:pt x="299558" y="1287266"/>
+                </a:cubicBezTo>
+                <a:cubicBezTo>
+                  <a:pt x="277380" y="1264010"/>
+                  <a:pt x="259203" y="1269909"/>
+                  <a:pt x="243216" y="1249403"/>
+                </a:cubicBezTo>
+                <a:cubicBezTo>
+                  <a:pt x="227230" y="1228898"/>
+                  <a:pt x="218454" y="1166841"/>
+                  <a:pt x="203639" y="1164232"/>
+                </a:cubicBezTo>
+                <a:cubicBezTo>
+                  <a:pt x="192352" y="1144923"/>
+                  <a:pt x="198158" y="1133798"/>
+                  <a:pt x="169195" y="1087898"/>
+                </a:cubicBezTo>
+                <a:cubicBezTo>
+                  <a:pt x="139228" y="1002950"/>
+                  <a:pt x="140891" y="969630"/>
+                  <a:pt x="98775" y="910071"/>
+                </a:cubicBezTo>
+                <a:cubicBezTo>
+                  <a:pt x="45025" y="831068"/>
+                  <a:pt x="34038" y="817468"/>
+                  <a:pt x="43820" y="712632"/>
+                </a:cubicBezTo>
+                <a:cubicBezTo>
+                  <a:pt x="34816" y="659496"/>
+                  <a:pt x="43273" y="613587"/>
+                  <a:pt x="44748" y="591246"/>
+                </a:cubicBezTo>
+                <a:lnTo>
+                  <a:pt x="36767" y="546725"/>
+                </a:lnTo>
+                <a:cubicBezTo>
+                  <a:pt x="36093" y="528360"/>
+                  <a:pt x="35418" y="509996"/>
+                  <a:pt x="34744" y="491632"/>
+                </a:cubicBezTo>
+                <a:cubicBezTo>
+                  <a:pt x="34670" y="458441"/>
+                  <a:pt x="29296" y="473054"/>
+                  <a:pt x="29222" y="439863"/>
+                </a:cubicBezTo>
+                <a:cubicBezTo>
+                  <a:pt x="29152" y="439762"/>
+                  <a:pt x="2578" y="397168"/>
+                  <a:pt x="2507" y="397065"/>
+                </a:cubicBezTo>
+                <a:cubicBezTo>
+                  <a:pt x="-7796" y="385479"/>
+                  <a:pt x="17492" y="336832"/>
+                  <a:pt x="9810" y="317232"/>
+                </a:cubicBezTo>
+                <a:lnTo>
+                  <a:pt x="25323" y="268841"/>
+                </a:lnTo>
+                <a:cubicBezTo>
+                  <a:pt x="20582" y="241406"/>
+                  <a:pt x="55391" y="238509"/>
+                  <a:pt x="50278" y="195107"/>
+                </a:cubicBezTo>
+                <a:cubicBezTo>
+                  <a:pt x="49891" y="157638"/>
+                  <a:pt x="41873" y="124837"/>
+                  <a:pt x="47653" y="93413"/>
+                </a:cubicBezTo>
+                <a:cubicBezTo>
+                  <a:pt x="41389" y="80245"/>
+                  <a:pt x="38874" y="67990"/>
+                  <a:pt x="48323" y="56668"/>
+                </a:cubicBezTo>
+                <a:cubicBezTo>
+                  <a:pt x="46028" y="30349"/>
+                  <a:pt x="37896" y="18658"/>
+                  <a:pt x="38423" y="5323"/>
+                </a:cubicBezTo>
+                <a:lnTo>
+                  <a:pt x="39875" y="1"/>
+                </a:lnTo>
+                <a:close/>
+              </a:path>
+            </a:pathLst>
+          </a:custGeom>
           <a:noFill/>
-          <a:ln w="9525">
-            <a:noFill/>
-            <a:headEnd/>
-            <a:tailEnd/>
-          </a:ln>
         </p:spPr>
       </p:pic>
+      <p:sp>
+        <p:nvSpPr>
+          <p:cNvPr id="2" name="Title 1"/>
+          <p:cNvSpPr>
+            <a:spLocks noGrp="1"/>
+          </p:cNvSpPr>
+          <p:nvPr>
+            <p:ph type="ctrTitle"/>
+          </p:nvPr>
+        </p:nvSpPr>
+        <p:spPr>
+          <a:xfrm>
+            <a:off x="496437" y="2139285"/>
+            <a:ext cx="2371455" cy="1980186"/>
+          </a:xfrm>
+        </p:spPr>
+        <p:txBody>
+          <a:bodyPr>
+            <a:normAutofit/>
+          </a:bodyPr>
+          <a:lstStyle/>
+          <a:p>
+            <a:pPr marL="0" lvl="0" indent="0" algn="l">
+              <a:buNone/>
+            </a:pPr>
+            <a:r>
+              <a:rPr lang="en-AU" sz="2700">
+                <a:solidFill>
+                  <a:schemeClr val="tx1">
+                    <a:lumMod val="85000"/>
+                    <a:lumOff val="15000"/>
+                  </a:schemeClr>
+                </a:solidFill>
+              </a:rPr>
+              <a:t>AI in Pedagogical Design and Delivery</a:t>
+            </a:r>
+          </a:p>
+        </p:txBody>
+      </p:sp>
+      <p:sp>
+        <p:nvSpPr>
+          <p:cNvPr id="3" name="Subtitle 2"/>
+          <p:cNvSpPr>
+            <a:spLocks noGrp="1"/>
+          </p:cNvSpPr>
+          <p:nvPr>
+            <p:ph type="subTitle" idx="1"/>
+          </p:nvPr>
+        </p:nvSpPr>
+        <p:spPr>
+          <a:xfrm>
+            <a:off x="496436" y="4257675"/>
+            <a:ext cx="2479567" cy="499352"/>
+          </a:xfrm>
+        </p:spPr>
+        <p:txBody>
+          <a:bodyPr>
+            <a:normAutofit/>
+          </a:bodyPr>
+          <a:lstStyle/>
+          <a:p>
+            <a:pPr marL="0" lvl="0" indent="0" algn="l">
+              <a:lnSpc>
+                <a:spcPct val="90000"/>
+              </a:lnSpc>
+              <a:buNone/>
+            </a:pPr>
+            <a:br>
+              <a:rPr lang="en-AU" sz="900">
+                <a:solidFill>
+                  <a:schemeClr val="tx1">
+                    <a:lumMod val="85000"/>
+                    <a:lumOff val="15000"/>
+                  </a:schemeClr>
+                </a:solidFill>
+              </a:rPr>
+            </a:br>
+            <a:br>
+              <a:rPr lang="en-AU" sz="900">
+                <a:solidFill>
+                  <a:schemeClr val="tx1">
+                    <a:lumMod val="85000"/>
+                    <a:lumOff val="15000"/>
+                  </a:schemeClr>
+                </a:solidFill>
+              </a:rPr>
+            </a:br>
+            <a:r>
+              <a:rPr lang="en-AU" sz="900">
+                <a:solidFill>
+                  <a:schemeClr val="tx1">
+                    <a:lumMod val="85000"/>
+                    <a:lumOff val="15000"/>
+                  </a:schemeClr>
+                </a:solidFill>
+              </a:rPr>
+              <a:t>Michael Borck</a:t>
+            </a:r>
+          </a:p>
+        </p:txBody>
+      </p:sp>
+      <p:sp>
+        <p:nvSpPr>
+          <p:cNvPr id="4" name="Date Placeholder 3"/>
+          <p:cNvSpPr>
+            <a:spLocks noGrp="1"/>
+          </p:cNvSpPr>
+          <p:nvPr>
+            <p:ph type="dt" sz="half" idx="10"/>
+          </p:nvPr>
+        </p:nvSpPr>
+        <p:spPr>
+          <a:xfrm>
+            <a:off x="628650" y="4767262"/>
+            <a:ext cx="2057400" cy="273844"/>
+          </a:xfrm>
+        </p:spPr>
+        <p:txBody>
+          <a:bodyPr>
+            <a:normAutofit/>
+          </a:bodyPr>
+          <a:lstStyle/>
+          <a:p>
+            <a:pPr marL="0" lvl="0" indent="0">
+              <a:spcAft>
+                <a:spcPts val="600"/>
+              </a:spcAft>
+              <a:buNone/>
+            </a:pPr>
+            <a:r>
+              <a:rPr lang="en-AU" sz="800">
+                <a:solidFill>
+                  <a:schemeClr val="tx1">
+                    <a:lumMod val="50000"/>
+                    <a:lumOff val="50000"/>
+                  </a:schemeClr>
+                </a:solidFill>
+              </a:rPr>
+              <a:t>2025-11-17</a:t>
+            </a:r>
+          </a:p>
+        </p:txBody>
+      </p:sp>
     </p:spTree>
   </p:cSld>
   <p:clrMapOvr>

</xml_diff>